<commit_message>
Add arrays sections slide
</commit_message>
<xml_diff>
--- a/openmp_gpu_offloading.pptx
+++ b/openmp_gpu_offloading.pptx
@@ -5,7 +5,7 @@
     <p:sldMasterId id="2147483648" r:id="rId1"/>
   </p:sldMasterIdLst>
   <p:notesMasterIdLst>
-    <p:notesMasterId r:id="rId26"/>
+    <p:notesMasterId r:id="rId27"/>
   </p:notesMasterIdLst>
   <p:sldIdLst>
     <p:sldId id="257" r:id="rId2"/>
@@ -26,12 +26,13 @@
     <p:sldId id="369" r:id="rId17"/>
     <p:sldId id="370" r:id="rId18"/>
     <p:sldId id="371" r:id="rId19"/>
-    <p:sldId id="373" r:id="rId20"/>
-    <p:sldId id="374" r:id="rId21"/>
-    <p:sldId id="375" r:id="rId22"/>
-    <p:sldId id="376" r:id="rId23"/>
-    <p:sldId id="372" r:id="rId24"/>
-    <p:sldId id="358" r:id="rId25"/>
+    <p:sldId id="377" r:id="rId20"/>
+    <p:sldId id="373" r:id="rId21"/>
+    <p:sldId id="374" r:id="rId22"/>
+    <p:sldId id="375" r:id="rId23"/>
+    <p:sldId id="376" r:id="rId24"/>
+    <p:sldId id="372" r:id="rId25"/>
+    <p:sldId id="358" r:id="rId26"/>
   </p:sldIdLst>
   <p:sldSz cx="12192000" cy="6858000"/>
   <p:notesSz cx="6858000" cy="9144000"/>
@@ -7483,7 +7484,7 @@
           <p:cNvPr id="2" name="Title 1">
             <a:extLst>
               <a:ext uri="{FF2B5EF4-FFF2-40B4-BE49-F238E27FC236}">
-                <a16:creationId xmlns:a16="http://schemas.microsoft.com/office/drawing/2014/main" id="{B572CA4C-F0C4-A6E1-3EB0-76C4786F3169}"/>
+                <a16:creationId xmlns:a16="http://schemas.microsoft.com/office/drawing/2014/main" id="{F5F86363-E3B5-71A2-3E51-BCCF17F37CBC}"/>
               </a:ext>
             </a:extLst>
           </p:cNvPr>
@@ -7501,7 +7502,7 @@
           <a:p>
             <a:r>
               <a:rPr lang="en-US" dirty="0"/>
-              <a:t>Creating teams</a:t>
+              <a:t>Array section syntax</a:t>
             </a:r>
             <a:endParaRPr lang="LID4096" dirty="0"/>
           </a:p>
@@ -7509,10 +7510,10 @@
       </p:sp>
       <p:sp>
         <p:nvSpPr>
-          <p:cNvPr id="3" name="Content Placeholder 2">
+          <p:cNvPr id="3" name="Text Placeholder 2">
             <a:extLst>
               <a:ext uri="{FF2B5EF4-FFF2-40B4-BE49-F238E27FC236}">
-                <a16:creationId xmlns:a16="http://schemas.microsoft.com/office/drawing/2014/main" id="{775BFE13-1B24-6A3F-3633-31FB9CA0FC0E}"/>
+                <a16:creationId xmlns:a16="http://schemas.microsoft.com/office/drawing/2014/main" id="{3093CFA0-D47F-F656-95DC-305AEC872969}"/>
               </a:ext>
             </a:extLst>
           </p:cNvPr>
@@ -7520,392 +7521,518 @@
             <a:spLocks noGrp="1"/>
           </p:cNvSpPr>
           <p:nvPr>
-            <p:ph idx="1"/>
+            <p:ph type="body" idx="1"/>
           </p:nvPr>
         </p:nvSpPr>
-        <p:spPr/>
+        <p:spPr>
+          <a:xfrm>
+            <a:off x="446497" y="1681163"/>
+            <a:ext cx="5649503" cy="823912"/>
+          </a:xfrm>
+        </p:spPr>
         <p:txBody>
           <a:bodyPr>
-            <a:normAutofit fontScale="92500" lnSpcReduction="20000"/>
+            <a:normAutofit/>
           </a:bodyPr>
           <a:lstStyle/>
           <a:p>
             <a:r>
-              <a:rPr lang="en-US" dirty="0"/>
-              <a:t>Example</a:t>
-            </a:r>
-            <a:br>
-              <a:rPr lang="en-US" dirty="0"/>
-            </a:br>
-            <a:r>
-              <a:rPr lang="en-US" dirty="0">
-                <a:solidFill>
-                  <a:prstClr val="black"/>
-                </a:solidFill>
-                <a:latin typeface="Courier New" pitchFamily="49" charset="0"/>
-                <a:cs typeface="Courier New" pitchFamily="49" charset="0"/>
-              </a:rPr>
-              <a:t>#pragma </a:t>
-            </a:r>
-            <a:r>
-              <a:rPr lang="en-US" dirty="0" err="1">
-                <a:solidFill>
-                  <a:prstClr val="black"/>
-                </a:solidFill>
-                <a:latin typeface="Courier New" pitchFamily="49" charset="0"/>
-                <a:cs typeface="Courier New" pitchFamily="49" charset="0"/>
-              </a:rPr>
-              <a:t>omp</a:t>
-            </a:r>
-            <a:r>
-              <a:rPr lang="en-US" dirty="0">
-                <a:solidFill>
-                  <a:prstClr val="black"/>
-                </a:solidFill>
-                <a:latin typeface="Courier New" pitchFamily="49" charset="0"/>
-                <a:cs typeface="Courier New" pitchFamily="49" charset="0"/>
-              </a:rPr>
-              <a:t> teams</a:t>
-            </a:r>
-          </a:p>
-          <a:p>
-            <a:endParaRPr lang="en-US" dirty="0">
-              <a:solidFill>
-                <a:prstClr val="black"/>
-              </a:solidFill>
-              <a:latin typeface="Courier New" pitchFamily="49" charset="0"/>
-              <a:cs typeface="Courier New" pitchFamily="49" charset="0"/>
-            </a:endParaRPr>
-          </a:p>
-          <a:p>
-            <a:r>
-              <a:rPr lang="en-US" dirty="0">
-                <a:solidFill>
-                  <a:prstClr val="black"/>
-                </a:solidFill>
-                <a:cs typeface="Courier New" pitchFamily="49" charset="0"/>
-              </a:rPr>
-              <a:t>Creates league of teams</a:t>
-            </a:r>
-          </a:p>
-          <a:p>
-            <a:r>
-              <a:rPr lang="en-US" dirty="0">
-                <a:solidFill>
-                  <a:prstClr val="black"/>
-                </a:solidFill>
-                <a:cs typeface="Courier New" pitchFamily="49" charset="0"/>
-              </a:rPr>
-              <a:t>Each team has single initial thread</a:t>
-            </a:r>
-          </a:p>
-          <a:p>
-            <a:endParaRPr lang="en-US" dirty="0">
-              <a:solidFill>
-                <a:prstClr val="black"/>
-              </a:solidFill>
-              <a:cs typeface="Courier New" pitchFamily="49" charset="0"/>
-            </a:endParaRPr>
-          </a:p>
-          <a:p>
-            <a:r>
-              <a:rPr lang="en-US" dirty="0">
-                <a:solidFill>
-                  <a:prstClr val="black"/>
-                </a:solidFill>
-                <a:cs typeface="Courier New" pitchFamily="49" charset="0"/>
-              </a:rPr>
-              <a:t>Clauses</a:t>
-            </a:r>
-          </a:p>
-          <a:p>
-            <a:pPr lvl="1"/>
-            <a:r>
-              <a:rPr lang="en-US" dirty="0">
-                <a:solidFill>
-                  <a:prstClr val="black"/>
-                </a:solidFill>
-                <a:latin typeface="Courier New" panose="02070309020205020404" pitchFamily="49" charset="0"/>
-                <a:cs typeface="Courier New" panose="02070309020205020404" pitchFamily="49" charset="0"/>
-              </a:rPr>
-              <a:t>private(</a:t>
-            </a:r>
-            <a:r>
-              <a:rPr lang="en-US" dirty="0">
-                <a:solidFill>
-                  <a:prstClr val="black"/>
-                </a:solidFill>
-                <a:latin typeface="Courier New" panose="02070309020205020404" pitchFamily="49" charset="0"/>
-                <a:cs typeface="Courier New" panose="02070309020205020404" pitchFamily="49" charset="0"/>
-                <a:sym typeface="Symbol" panose="05050102010706020507" pitchFamily="18" charset="2"/>
-              </a:rPr>
-              <a:t>)</a:t>
-            </a:r>
-            <a:r>
-              <a:rPr lang="en-US" dirty="0">
-                <a:solidFill>
-                  <a:prstClr val="black"/>
-                </a:solidFill>
-                <a:cs typeface="Courier New" pitchFamily="49" charset="0"/>
-              </a:rPr>
-              <a:t>, </a:t>
-            </a:r>
-            <a:r>
-              <a:rPr lang="en-US" dirty="0" err="1">
-                <a:solidFill>
-                  <a:prstClr val="black"/>
-                </a:solidFill>
-                <a:latin typeface="Courier New" panose="02070309020205020404" pitchFamily="49" charset="0"/>
-                <a:cs typeface="Courier New" panose="02070309020205020404" pitchFamily="49" charset="0"/>
-              </a:rPr>
-              <a:t>firstprivate</a:t>
-            </a:r>
-            <a:r>
-              <a:rPr lang="en-US" dirty="0">
-                <a:solidFill>
-                  <a:prstClr val="black"/>
-                </a:solidFill>
-                <a:latin typeface="Courier New" panose="02070309020205020404" pitchFamily="49" charset="0"/>
-                <a:cs typeface="Courier New" panose="02070309020205020404" pitchFamily="49" charset="0"/>
-              </a:rPr>
-              <a:t>(</a:t>
-            </a:r>
-            <a:r>
-              <a:rPr lang="en-US" dirty="0">
-                <a:solidFill>
-                  <a:prstClr val="black"/>
-                </a:solidFill>
-                <a:latin typeface="Courier New" panose="02070309020205020404" pitchFamily="49" charset="0"/>
-                <a:cs typeface="Courier New" panose="02070309020205020404" pitchFamily="49" charset="0"/>
-                <a:sym typeface="Symbol" panose="05050102010706020507" pitchFamily="18" charset="2"/>
-              </a:rPr>
-              <a:t>)</a:t>
-            </a:r>
-            <a:r>
-              <a:rPr lang="en-US" dirty="0">
-                <a:solidFill>
-                  <a:prstClr val="black"/>
-                </a:solidFill>
-                <a:cs typeface="Courier New" pitchFamily="49" charset="0"/>
-              </a:rPr>
-              <a:t>, </a:t>
-            </a:r>
-            <a:r>
-              <a:rPr lang="en-US" dirty="0">
-                <a:solidFill>
-                  <a:prstClr val="black"/>
-                </a:solidFill>
-                <a:latin typeface="Courier New" panose="02070309020205020404" pitchFamily="49" charset="0"/>
-                <a:cs typeface="Courier New" panose="02070309020205020404" pitchFamily="49" charset="0"/>
-              </a:rPr>
-              <a:t>shared(</a:t>
-            </a:r>
-            <a:r>
-              <a:rPr lang="en-US" dirty="0">
-                <a:solidFill>
-                  <a:prstClr val="black"/>
-                </a:solidFill>
-                <a:latin typeface="Courier New" panose="02070309020205020404" pitchFamily="49" charset="0"/>
-                <a:cs typeface="Courier New" panose="02070309020205020404" pitchFamily="49" charset="0"/>
-                <a:sym typeface="Symbol" panose="05050102010706020507" pitchFamily="18" charset="2"/>
-              </a:rPr>
-              <a:t>)</a:t>
-            </a:r>
-            <a:r>
-              <a:rPr lang="en-US" dirty="0">
-                <a:solidFill>
-                  <a:prstClr val="black"/>
-                </a:solidFill>
-                <a:cs typeface="Courier New" pitchFamily="49" charset="0"/>
-              </a:rPr>
-              <a:t>, </a:t>
-            </a:r>
-            <a:r>
-              <a:rPr lang="en-US" dirty="0">
-                <a:solidFill>
-                  <a:prstClr val="black"/>
-                </a:solidFill>
-                <a:latin typeface="Courier New" panose="02070309020205020404" pitchFamily="49" charset="0"/>
-                <a:cs typeface="Courier New" panose="02070309020205020404" pitchFamily="49" charset="0"/>
-              </a:rPr>
-              <a:t>default(</a:t>
-            </a:r>
-            <a:r>
-              <a:rPr lang="en-US" dirty="0">
-                <a:solidFill>
-                  <a:prstClr val="black"/>
-                </a:solidFill>
-                <a:latin typeface="Courier New" panose="02070309020205020404" pitchFamily="49" charset="0"/>
-                <a:cs typeface="Courier New" panose="02070309020205020404" pitchFamily="49" charset="0"/>
-                <a:sym typeface="Symbol" panose="05050102010706020507" pitchFamily="18" charset="2"/>
-              </a:rPr>
-              <a:t>)</a:t>
-            </a:r>
-            <a:r>
-              <a:rPr lang="en-US" dirty="0">
-                <a:solidFill>
-                  <a:prstClr val="black"/>
-                </a:solidFill>
-                <a:cs typeface="Courier New" pitchFamily="49" charset="0"/>
-              </a:rPr>
-              <a:t>, </a:t>
-            </a:r>
-            <a:r>
-              <a:rPr lang="en-US" dirty="0">
-                <a:solidFill>
-                  <a:prstClr val="black"/>
-                </a:solidFill>
-                <a:latin typeface="Courier New" panose="02070309020205020404" pitchFamily="49" charset="0"/>
-                <a:cs typeface="Courier New" panose="02070309020205020404" pitchFamily="49" charset="0"/>
-              </a:rPr>
-              <a:t>reduction(</a:t>
-            </a:r>
-            <a:r>
-              <a:rPr lang="en-US" dirty="0">
-                <a:solidFill>
-                  <a:prstClr val="black"/>
-                </a:solidFill>
-                <a:latin typeface="Courier New" panose="02070309020205020404" pitchFamily="49" charset="0"/>
-                <a:cs typeface="Courier New" panose="02070309020205020404" pitchFamily="49" charset="0"/>
-                <a:sym typeface="Symbol" panose="05050102010706020507" pitchFamily="18" charset="2"/>
-              </a:rPr>
-              <a:t>)</a:t>
-            </a:r>
-            <a:r>
-              <a:rPr lang="en-US" dirty="0">
-                <a:solidFill>
-                  <a:prstClr val="black"/>
-                </a:solidFill>
-                <a:cs typeface="Courier New" pitchFamily="49" charset="0"/>
-              </a:rPr>
-              <a:t>, </a:t>
-            </a:r>
-            <a:r>
-              <a:rPr lang="en-US" dirty="0">
-                <a:solidFill>
-                  <a:prstClr val="black"/>
-                </a:solidFill>
-                <a:latin typeface="Courier New" panose="02070309020205020404" pitchFamily="49" charset="0"/>
-                <a:cs typeface="Courier New" panose="02070309020205020404" pitchFamily="49" charset="0"/>
-              </a:rPr>
-              <a:t>if(</a:t>
-            </a:r>
-            <a:r>
-              <a:rPr lang="en-US" dirty="0">
-                <a:solidFill>
-                  <a:prstClr val="black"/>
-                </a:solidFill>
-                <a:latin typeface="Courier New" panose="02070309020205020404" pitchFamily="49" charset="0"/>
-                <a:cs typeface="Courier New" panose="02070309020205020404" pitchFamily="49" charset="0"/>
-                <a:sym typeface="Symbol" panose="05050102010706020507" pitchFamily="18" charset="2"/>
-              </a:rPr>
-              <a:t>)</a:t>
-            </a:r>
-            <a:endParaRPr lang="en-US" dirty="0">
-              <a:solidFill>
-                <a:prstClr val="black"/>
-              </a:solidFill>
-              <a:latin typeface="Courier New" panose="02070309020205020404" pitchFamily="49" charset="0"/>
-              <a:cs typeface="Courier New" panose="02070309020205020404" pitchFamily="49" charset="0"/>
-            </a:endParaRPr>
-          </a:p>
-          <a:p>
-            <a:pPr lvl="1"/>
-            <a:r>
-              <a:rPr lang="en-US" dirty="0" err="1">
-                <a:solidFill>
-                  <a:prstClr val="black"/>
-                </a:solidFill>
-                <a:latin typeface="Courier New" panose="02070309020205020404" pitchFamily="49" charset="0"/>
-                <a:cs typeface="Courier New" panose="02070309020205020404" pitchFamily="49" charset="0"/>
-              </a:rPr>
-              <a:t>num_teams</a:t>
-            </a:r>
-            <a:r>
-              <a:rPr lang="en-US" dirty="0">
-                <a:solidFill>
-                  <a:prstClr val="black"/>
-                </a:solidFill>
-                <a:latin typeface="Courier New" panose="02070309020205020404" pitchFamily="49" charset="0"/>
-                <a:cs typeface="Courier New" panose="02070309020205020404" pitchFamily="49" charset="0"/>
-              </a:rPr>
-              <a:t>(</a:t>
-            </a:r>
-            <a:r>
-              <a:rPr lang="en-US" dirty="0">
-                <a:solidFill>
-                  <a:prstClr val="black"/>
-                </a:solidFill>
-                <a:latin typeface="Courier New" panose="02070309020205020404" pitchFamily="49" charset="0"/>
-                <a:cs typeface="Courier New" panose="02070309020205020404" pitchFamily="49" charset="0"/>
-                <a:sym typeface="Symbol" panose="05050102010706020507" pitchFamily="18" charset="2"/>
-              </a:rPr>
-              <a:t>)</a:t>
-            </a:r>
-            <a:endParaRPr lang="en-US" dirty="0">
-              <a:solidFill>
-                <a:prstClr val="black"/>
-              </a:solidFill>
-              <a:latin typeface="Courier New" panose="02070309020205020404" pitchFamily="49" charset="0"/>
-              <a:cs typeface="Courier New" panose="02070309020205020404" pitchFamily="49" charset="0"/>
-            </a:endParaRPr>
-          </a:p>
-          <a:p>
-            <a:pPr lvl="1"/>
-            <a:r>
-              <a:rPr lang="en-US" dirty="0" err="1">
-                <a:solidFill>
-                  <a:prstClr val="black"/>
-                </a:solidFill>
-                <a:latin typeface="Courier New" panose="02070309020205020404" pitchFamily="49" charset="0"/>
-                <a:cs typeface="Courier New" panose="02070309020205020404" pitchFamily="49" charset="0"/>
-              </a:rPr>
-              <a:t>thread_limit</a:t>
-            </a:r>
-            <a:r>
-              <a:rPr lang="en-US" dirty="0">
-                <a:solidFill>
-                  <a:prstClr val="black"/>
-                </a:solidFill>
-                <a:latin typeface="Courier New" panose="02070309020205020404" pitchFamily="49" charset="0"/>
-                <a:cs typeface="Courier New" panose="02070309020205020404" pitchFamily="49" charset="0"/>
-              </a:rPr>
-              <a:t>(</a:t>
-            </a:r>
-            <a:r>
-              <a:rPr lang="en-US" dirty="0">
-                <a:solidFill>
-                  <a:prstClr val="black"/>
-                </a:solidFill>
-                <a:latin typeface="Courier New" panose="02070309020205020404" pitchFamily="49" charset="0"/>
-                <a:cs typeface="Courier New" panose="02070309020205020404" pitchFamily="49" charset="0"/>
-                <a:sym typeface="Symbol" panose="05050102010706020507" pitchFamily="18" charset="2"/>
-              </a:rPr>
-              <a:t>)</a:t>
-            </a:r>
-          </a:p>
-          <a:p>
-            <a:pPr lvl="1"/>
-            <a:r>
-              <a:rPr lang="en-US" dirty="0">
-                <a:solidFill>
-                  <a:prstClr val="black"/>
-                </a:solidFill>
-                <a:cs typeface="Courier New" pitchFamily="49" charset="0"/>
-                <a:sym typeface="Symbol" panose="05050102010706020507" pitchFamily="18" charset="2"/>
-              </a:rPr>
-              <a:t></a:t>
-            </a:r>
-            <a:endParaRPr lang="LID4096" dirty="0"/>
+              <a:rPr lang="en-US" sz="3200" dirty="0"/>
+              <a:t>C and C++</a:t>
+            </a:r>
+            <a:endParaRPr lang="LID4096" sz="3200" dirty="0"/>
           </a:p>
         </p:txBody>
       </p:sp>
       <p:sp>
         <p:nvSpPr>
-          <p:cNvPr id="4" name="Slide Number Placeholder 3">
+          <p:cNvPr id="4" name="Content Placeholder 3">
             <a:extLst>
               <a:ext uri="{FF2B5EF4-FFF2-40B4-BE49-F238E27FC236}">
-                <a16:creationId xmlns:a16="http://schemas.microsoft.com/office/drawing/2014/main" id="{849DE019-3110-99A0-75BE-DDBC7982872A}"/>
+                <a16:creationId xmlns:a16="http://schemas.microsoft.com/office/drawing/2014/main" id="{6F3467AF-1D4D-FA50-1278-2BCD19214259}"/>
+              </a:ext>
+            </a:extLst>
+          </p:cNvPr>
+          <p:cNvSpPr>
+            <a:spLocks noGrp="1"/>
+          </p:cNvSpPr>
+          <p:nvPr>
+            <p:ph sz="half" idx="2"/>
+          </p:nvPr>
+        </p:nvSpPr>
+        <p:spPr>
+          <a:xfrm>
+            <a:off x="446497" y="2505075"/>
+            <a:ext cx="5649503" cy="3684588"/>
+          </a:xfrm>
+        </p:spPr>
+        <p:txBody>
+          <a:bodyPr>
+            <a:normAutofit/>
+          </a:bodyPr>
+          <a:lstStyle/>
+          <a:p>
+            <a:r>
+              <a:rPr lang="en-US" sz="2400" dirty="0">
+                <a:latin typeface="Courier New" panose="02070309020205020404" pitchFamily="49" charset="0"/>
+                <a:cs typeface="Courier New" panose="02070309020205020404" pitchFamily="49" charset="0"/>
+              </a:rPr>
+              <a:t>A[&lt;first&gt;:&lt;length&gt;:&lt;stride&gt;]</a:t>
+            </a:r>
+            <a:endParaRPr lang="en-US" dirty="0">
+              <a:latin typeface="Courier New" panose="02070309020205020404" pitchFamily="49" charset="0"/>
+              <a:cs typeface="Courier New" panose="02070309020205020404" pitchFamily="49" charset="0"/>
+            </a:endParaRPr>
+          </a:p>
+          <a:p>
+            <a:endParaRPr lang="en-US" dirty="0"/>
+          </a:p>
+          <a:p>
+            <a:r>
+              <a:rPr lang="en-US" dirty="0"/>
+              <a:t>Example: </a:t>
+            </a:r>
+            <a:r>
+              <a:rPr lang="en-US" dirty="0">
+                <a:latin typeface="Courier New" panose="02070309020205020404" pitchFamily="49" charset="0"/>
+                <a:cs typeface="Courier New" panose="02070309020205020404" pitchFamily="49" charset="0"/>
+              </a:rPr>
+              <a:t>A[10]</a:t>
+            </a:r>
+          </a:p>
+          <a:p>
+            <a:pPr lvl="1"/>
+            <a:r>
+              <a:rPr lang="en-US" sz="2000" dirty="0">
+                <a:latin typeface="Courier New" panose="02070309020205020404" pitchFamily="49" charset="0"/>
+                <a:cs typeface="Courier New" panose="02070309020205020404" pitchFamily="49" charset="0"/>
+              </a:rPr>
+              <a:t>A[:10]</a:t>
+            </a:r>
+            <a:r>
+              <a:rPr lang="en-US" sz="2000" dirty="0"/>
+              <a:t>: </a:t>
+            </a:r>
+            <a:r>
+              <a:rPr lang="en-US" sz="2000" dirty="0">
+                <a:latin typeface="Courier New" panose="02070309020205020404" pitchFamily="49" charset="0"/>
+                <a:cs typeface="Courier New" panose="02070309020205020404" pitchFamily="49" charset="0"/>
+              </a:rPr>
+              <a:t>A[0]</a:t>
+            </a:r>
+            <a:r>
+              <a:rPr lang="en-US" sz="2000" dirty="0"/>
+              <a:t>, </a:t>
+            </a:r>
+            <a:r>
+              <a:rPr lang="en-US" sz="2000" dirty="0">
+                <a:sym typeface="Symbol" panose="05050102010706020507" pitchFamily="18" charset="2"/>
+              </a:rPr>
+              <a:t></a:t>
+            </a:r>
+            <a:r>
+              <a:rPr lang="en-US" sz="2000" dirty="0"/>
+              <a:t>, </a:t>
+            </a:r>
+            <a:r>
+              <a:rPr lang="en-US" sz="2000" dirty="0">
+                <a:latin typeface="Courier New" panose="02070309020205020404" pitchFamily="49" charset="0"/>
+                <a:cs typeface="Courier New" panose="02070309020205020404" pitchFamily="49" charset="0"/>
+              </a:rPr>
+              <a:t>A[9]</a:t>
+            </a:r>
+          </a:p>
+          <a:p>
+            <a:pPr lvl="1"/>
+            <a:r>
+              <a:rPr lang="en-US" sz="2000" dirty="0">
+                <a:latin typeface="Courier New" panose="02070309020205020404" pitchFamily="49" charset="0"/>
+                <a:cs typeface="Courier New" panose="02070309020205020404" pitchFamily="49" charset="0"/>
+              </a:rPr>
+              <a:t>A[2:4]</a:t>
+            </a:r>
+            <a:r>
+              <a:rPr lang="en-US" sz="2000" dirty="0"/>
+              <a:t>: </a:t>
+            </a:r>
+            <a:r>
+              <a:rPr lang="en-US" sz="2000" dirty="0">
+                <a:latin typeface="Courier New" panose="02070309020205020404" pitchFamily="49" charset="0"/>
+                <a:cs typeface="Courier New" panose="02070309020205020404" pitchFamily="49" charset="0"/>
+              </a:rPr>
+              <a:t>A[2]</a:t>
+            </a:r>
+            <a:r>
+              <a:rPr lang="en-US" sz="2000" dirty="0"/>
+              <a:t>, </a:t>
+            </a:r>
+            <a:r>
+              <a:rPr lang="en-US" sz="2000" dirty="0">
+                <a:latin typeface="Courier New" panose="02070309020205020404" pitchFamily="49" charset="0"/>
+                <a:cs typeface="Courier New" panose="02070309020205020404" pitchFamily="49" charset="0"/>
+              </a:rPr>
+              <a:t>A[3]</a:t>
+            </a:r>
+            <a:r>
+              <a:rPr lang="en-US" sz="2000" dirty="0"/>
+              <a:t>, </a:t>
+            </a:r>
+            <a:r>
+              <a:rPr lang="en-US" sz="2000" dirty="0">
+                <a:latin typeface="Courier New" panose="02070309020205020404" pitchFamily="49" charset="0"/>
+                <a:cs typeface="Courier New" panose="02070309020205020404" pitchFamily="49" charset="0"/>
+              </a:rPr>
+              <a:t>A[4]</a:t>
+            </a:r>
+            <a:r>
+              <a:rPr lang="en-US" sz="2000" dirty="0"/>
+              <a:t>, </a:t>
+            </a:r>
+            <a:r>
+              <a:rPr lang="en-US" sz="2000" dirty="0">
+                <a:latin typeface="Courier New" panose="02070309020205020404" pitchFamily="49" charset="0"/>
+                <a:cs typeface="Courier New" panose="02070309020205020404" pitchFamily="49" charset="0"/>
+              </a:rPr>
+              <a:t>A[5]</a:t>
+            </a:r>
+          </a:p>
+          <a:p>
+            <a:pPr lvl="1"/>
+            <a:r>
+              <a:rPr lang="en-US" sz="2000" dirty="0">
+                <a:latin typeface="Courier New" panose="02070309020205020404" pitchFamily="49" charset="0"/>
+                <a:cs typeface="Courier New" panose="02070309020205020404" pitchFamily="49" charset="0"/>
+              </a:rPr>
+              <a:t>A[1:4:2]</a:t>
+            </a:r>
+            <a:r>
+              <a:rPr lang="en-US" sz="2000" dirty="0"/>
+              <a:t>: </a:t>
+            </a:r>
+            <a:r>
+              <a:rPr lang="en-US" sz="2000" dirty="0">
+                <a:latin typeface="Courier New" panose="02070309020205020404" pitchFamily="49" charset="0"/>
+                <a:cs typeface="Courier New" panose="02070309020205020404" pitchFamily="49" charset="0"/>
+              </a:rPr>
+              <a:t>A[1]</a:t>
+            </a:r>
+            <a:r>
+              <a:rPr lang="en-US" sz="2000" dirty="0">
+                <a:cs typeface="Courier New" panose="02070309020205020404" pitchFamily="49" charset="0"/>
+              </a:rPr>
+              <a:t>, </a:t>
+            </a:r>
+            <a:r>
+              <a:rPr lang="en-US" sz="2000" dirty="0">
+                <a:latin typeface="Courier New" panose="02070309020205020404" pitchFamily="49" charset="0"/>
+                <a:cs typeface="Courier New" panose="02070309020205020404" pitchFamily="49" charset="0"/>
+              </a:rPr>
+              <a:t>A[3]</a:t>
+            </a:r>
+            <a:r>
+              <a:rPr lang="en-US" sz="2000" dirty="0">
+                <a:cs typeface="Courier New" panose="02070309020205020404" pitchFamily="49" charset="0"/>
+              </a:rPr>
+              <a:t>, </a:t>
+            </a:r>
+            <a:r>
+              <a:rPr lang="en-US" sz="2000" dirty="0">
+                <a:latin typeface="Courier New" panose="02070309020205020404" pitchFamily="49" charset="0"/>
+                <a:cs typeface="Courier New" panose="02070309020205020404" pitchFamily="49" charset="0"/>
+              </a:rPr>
+              <a:t>A[5]</a:t>
+            </a:r>
+            <a:r>
+              <a:rPr lang="en-US" sz="2000" dirty="0">
+                <a:cs typeface="Courier New" panose="02070309020205020404" pitchFamily="49" charset="0"/>
+              </a:rPr>
+              <a:t>, </a:t>
+            </a:r>
+            <a:r>
+              <a:rPr lang="en-US" sz="2000" dirty="0">
+                <a:latin typeface="Courier New" panose="02070309020205020404" pitchFamily="49" charset="0"/>
+                <a:cs typeface="Courier New" panose="02070309020205020404" pitchFamily="49" charset="0"/>
+              </a:rPr>
+              <a:t>A[7]</a:t>
+            </a:r>
+            <a:endParaRPr lang="en-US" dirty="0">
+              <a:latin typeface="Courier New" panose="02070309020205020404" pitchFamily="49" charset="0"/>
+              <a:cs typeface="Courier New" panose="02070309020205020404" pitchFamily="49" charset="0"/>
+            </a:endParaRPr>
+          </a:p>
+          <a:p>
+            <a:r>
+              <a:rPr lang="en-US" dirty="0"/>
+              <a:t>Example: </a:t>
+            </a:r>
+            <a:r>
+              <a:rPr lang="en-US" dirty="0">
+                <a:latin typeface="Courier New" panose="02070309020205020404" pitchFamily="49" charset="0"/>
+                <a:cs typeface="Courier New" panose="02070309020205020404" pitchFamily="49" charset="0"/>
+              </a:rPr>
+              <a:t>A[10][5]</a:t>
+            </a:r>
+          </a:p>
+          <a:p>
+            <a:pPr lvl="1"/>
+            <a:r>
+              <a:rPr lang="en-US" sz="2000" dirty="0">
+                <a:latin typeface="Courier New" panose="02070309020205020404" pitchFamily="49" charset="0"/>
+                <a:cs typeface="Courier New" panose="02070309020205020404" pitchFamily="49" charset="0"/>
+              </a:rPr>
+              <a:t>A[0:5][2:]</a:t>
+            </a:r>
+            <a:endParaRPr lang="LID4096" dirty="0">
+              <a:latin typeface="Courier New" panose="02070309020205020404" pitchFamily="49" charset="0"/>
+              <a:cs typeface="Courier New" panose="02070309020205020404" pitchFamily="49" charset="0"/>
+            </a:endParaRPr>
+          </a:p>
+        </p:txBody>
+      </p:sp>
+      <p:sp>
+        <p:nvSpPr>
+          <p:cNvPr id="5" name="Text Placeholder 4">
+            <a:extLst>
+              <a:ext uri="{FF2B5EF4-FFF2-40B4-BE49-F238E27FC236}">
+                <a16:creationId xmlns:a16="http://schemas.microsoft.com/office/drawing/2014/main" id="{59B6AD2E-CCDA-7352-C358-AC1023D228B4}"/>
+              </a:ext>
+            </a:extLst>
+          </p:cNvPr>
+          <p:cNvSpPr>
+            <a:spLocks noGrp="1"/>
+          </p:cNvSpPr>
+          <p:nvPr>
+            <p:ph type="body" sz="quarter" idx="3"/>
+          </p:nvPr>
+        </p:nvSpPr>
+        <p:spPr>
+          <a:xfrm>
+            <a:off x="6663812" y="1681163"/>
+            <a:ext cx="5183188" cy="823912"/>
+          </a:xfrm>
+        </p:spPr>
+        <p:txBody>
+          <a:bodyPr>
+            <a:normAutofit/>
+          </a:bodyPr>
+          <a:lstStyle/>
+          <a:p>
+            <a:r>
+              <a:rPr lang="en-US" sz="3200" dirty="0"/>
+              <a:t>Fortran</a:t>
+            </a:r>
+            <a:endParaRPr lang="LID4096" sz="3200" dirty="0"/>
+          </a:p>
+        </p:txBody>
+      </p:sp>
+      <p:sp>
+        <p:nvSpPr>
+          <p:cNvPr id="6" name="Content Placeholder 5">
+            <a:extLst>
+              <a:ext uri="{FF2B5EF4-FFF2-40B4-BE49-F238E27FC236}">
+                <a16:creationId xmlns:a16="http://schemas.microsoft.com/office/drawing/2014/main" id="{8793E819-8F6D-9C92-60A0-1765FC71E482}"/>
+              </a:ext>
+            </a:extLst>
+          </p:cNvPr>
+          <p:cNvSpPr>
+            <a:spLocks noGrp="1"/>
+          </p:cNvSpPr>
+          <p:nvPr>
+            <p:ph sz="quarter" idx="4"/>
+          </p:nvPr>
+        </p:nvSpPr>
+        <p:spPr>
+          <a:xfrm>
+            <a:off x="6663812" y="2505075"/>
+            <a:ext cx="5183188" cy="3684588"/>
+          </a:xfrm>
+        </p:spPr>
+        <p:txBody>
+          <a:bodyPr>
+            <a:normAutofit/>
+          </a:bodyPr>
+          <a:lstStyle/>
+          <a:p>
+            <a:r>
+              <a:rPr lang="en-US" sz="2400" dirty="0">
+                <a:latin typeface="Courier New" panose="02070309020205020404" pitchFamily="49" charset="0"/>
+                <a:cs typeface="Courier New" panose="02070309020205020404" pitchFamily="49" charset="0"/>
+              </a:rPr>
+              <a:t>A(&lt;first&gt;:&lt;last&gt;:&lt;stride&gt;)</a:t>
+            </a:r>
+          </a:p>
+          <a:p>
+            <a:endParaRPr lang="en-US" dirty="0"/>
+          </a:p>
+          <a:p>
+            <a:r>
+              <a:rPr lang="en-US" dirty="0"/>
+              <a:t>Example: </a:t>
+            </a:r>
+            <a:r>
+              <a:rPr lang="en-US" dirty="0">
+                <a:latin typeface="Courier New" panose="02070309020205020404" pitchFamily="49" charset="0"/>
+                <a:cs typeface="Courier New" panose="02070309020205020404" pitchFamily="49" charset="0"/>
+              </a:rPr>
+              <a:t>A(10)</a:t>
+            </a:r>
+          </a:p>
+          <a:p>
+            <a:pPr lvl="1"/>
+            <a:r>
+              <a:rPr lang="en-US" sz="2000" dirty="0">
+                <a:latin typeface="Courier New" panose="02070309020205020404" pitchFamily="49" charset="0"/>
+                <a:cs typeface="Courier New" panose="02070309020205020404" pitchFamily="49" charset="0"/>
+              </a:rPr>
+              <a:t>A(:10)</a:t>
+            </a:r>
+            <a:r>
+              <a:rPr lang="en-US" sz="2000" dirty="0"/>
+              <a:t>: </a:t>
+            </a:r>
+            <a:r>
+              <a:rPr lang="en-US" sz="2000" dirty="0">
+                <a:latin typeface="Courier New" panose="02070309020205020404" pitchFamily="49" charset="0"/>
+                <a:cs typeface="Courier New" panose="02070309020205020404" pitchFamily="49" charset="0"/>
+              </a:rPr>
+              <a:t>A(1)</a:t>
+            </a:r>
+            <a:r>
+              <a:rPr lang="en-US" sz="2000" dirty="0"/>
+              <a:t>, </a:t>
+            </a:r>
+            <a:r>
+              <a:rPr lang="en-US" sz="2000" dirty="0">
+                <a:sym typeface="Symbol" panose="05050102010706020507" pitchFamily="18" charset="2"/>
+              </a:rPr>
+              <a:t></a:t>
+            </a:r>
+            <a:r>
+              <a:rPr lang="en-US" sz="2000" dirty="0"/>
+              <a:t>, </a:t>
+            </a:r>
+            <a:r>
+              <a:rPr lang="en-US" sz="2000" dirty="0">
+                <a:latin typeface="Courier New" panose="02070309020205020404" pitchFamily="49" charset="0"/>
+                <a:cs typeface="Courier New" panose="02070309020205020404" pitchFamily="49" charset="0"/>
+              </a:rPr>
+              <a:t>A(10)</a:t>
+            </a:r>
+          </a:p>
+          <a:p>
+            <a:pPr lvl="1"/>
+            <a:r>
+              <a:rPr lang="en-US" sz="2000" dirty="0">
+                <a:latin typeface="Courier New" panose="02070309020205020404" pitchFamily="49" charset="0"/>
+                <a:cs typeface="Courier New" panose="02070309020205020404" pitchFamily="49" charset="0"/>
+              </a:rPr>
+              <a:t>A(2:4)</a:t>
+            </a:r>
+            <a:r>
+              <a:rPr lang="en-US" sz="2000" dirty="0"/>
+              <a:t>: </a:t>
+            </a:r>
+            <a:r>
+              <a:rPr lang="en-US" sz="2000" dirty="0">
+                <a:latin typeface="Courier New" panose="02070309020205020404" pitchFamily="49" charset="0"/>
+                <a:cs typeface="Courier New" panose="02070309020205020404" pitchFamily="49" charset="0"/>
+              </a:rPr>
+              <a:t>A(2)</a:t>
+            </a:r>
+            <a:r>
+              <a:rPr lang="en-US" sz="2000" dirty="0"/>
+              <a:t>, </a:t>
+            </a:r>
+            <a:r>
+              <a:rPr lang="en-US" sz="2000" dirty="0">
+                <a:latin typeface="Courier New" panose="02070309020205020404" pitchFamily="49" charset="0"/>
+                <a:cs typeface="Courier New" panose="02070309020205020404" pitchFamily="49" charset="0"/>
+              </a:rPr>
+              <a:t>A(3)</a:t>
+            </a:r>
+            <a:r>
+              <a:rPr lang="en-US" sz="2000" dirty="0"/>
+              <a:t>, </a:t>
+            </a:r>
+            <a:r>
+              <a:rPr lang="en-US" sz="2000" dirty="0">
+                <a:latin typeface="Courier New" panose="02070309020205020404" pitchFamily="49" charset="0"/>
+                <a:cs typeface="Courier New" panose="02070309020205020404" pitchFamily="49" charset="0"/>
+              </a:rPr>
+              <a:t>A(4)</a:t>
+            </a:r>
+          </a:p>
+          <a:p>
+            <a:pPr lvl="1"/>
+            <a:r>
+              <a:rPr lang="en-US" sz="2000" dirty="0">
+                <a:latin typeface="Courier New" panose="02070309020205020404" pitchFamily="49" charset="0"/>
+                <a:cs typeface="Courier New" panose="02070309020205020404" pitchFamily="49" charset="0"/>
+              </a:rPr>
+              <a:t>A(1:4:2)</a:t>
+            </a:r>
+            <a:r>
+              <a:rPr lang="en-US" sz="2000" dirty="0"/>
+              <a:t>: </a:t>
+            </a:r>
+            <a:r>
+              <a:rPr lang="en-US" sz="2000" dirty="0">
+                <a:latin typeface="Courier New" panose="02070309020205020404" pitchFamily="49" charset="0"/>
+                <a:cs typeface="Courier New" panose="02070309020205020404" pitchFamily="49" charset="0"/>
+              </a:rPr>
+              <a:t>A(1)</a:t>
+            </a:r>
+            <a:r>
+              <a:rPr lang="en-US" sz="2000" dirty="0"/>
+              <a:t>, </a:t>
+            </a:r>
+            <a:r>
+              <a:rPr lang="en-US" sz="2000" dirty="0">
+                <a:latin typeface="Courier New" panose="02070309020205020404" pitchFamily="49" charset="0"/>
+                <a:cs typeface="Courier New" panose="02070309020205020404" pitchFamily="49" charset="0"/>
+              </a:rPr>
+              <a:t>A(3)</a:t>
+            </a:r>
+            <a:endParaRPr lang="en-US" dirty="0">
+              <a:latin typeface="Courier New" panose="02070309020205020404" pitchFamily="49" charset="0"/>
+              <a:cs typeface="Courier New" panose="02070309020205020404" pitchFamily="49" charset="0"/>
+            </a:endParaRPr>
+          </a:p>
+          <a:p>
+            <a:r>
+              <a:rPr lang="en-US" dirty="0"/>
+              <a:t>Example: </a:t>
+            </a:r>
+            <a:r>
+              <a:rPr lang="en-US" dirty="0">
+                <a:latin typeface="Courier New" panose="02070309020205020404" pitchFamily="49" charset="0"/>
+                <a:cs typeface="Courier New" panose="02070309020205020404" pitchFamily="49" charset="0"/>
+              </a:rPr>
+              <a:t>A(10, 5)</a:t>
+            </a:r>
+          </a:p>
+          <a:p>
+            <a:pPr lvl="1"/>
+            <a:r>
+              <a:rPr lang="en-US" dirty="0">
+                <a:latin typeface="Courier New" panose="02070309020205020404" pitchFamily="49" charset="0"/>
+                <a:cs typeface="Courier New" panose="02070309020205020404" pitchFamily="49" charset="0"/>
+              </a:rPr>
+              <a:t>A(1:5, 3:)</a:t>
+            </a:r>
+            <a:endParaRPr lang="LID4096" dirty="0">
+              <a:latin typeface="Courier New" panose="02070309020205020404" pitchFamily="49" charset="0"/>
+              <a:cs typeface="Courier New" panose="02070309020205020404" pitchFamily="49" charset="0"/>
+            </a:endParaRPr>
+          </a:p>
+        </p:txBody>
+      </p:sp>
+      <p:sp>
+        <p:nvSpPr>
+          <p:cNvPr id="7" name="Slide Number Placeholder 6">
+            <a:extLst>
+              <a:ext uri="{FF2B5EF4-FFF2-40B4-BE49-F238E27FC236}">
+                <a16:creationId xmlns:a16="http://schemas.microsoft.com/office/drawing/2014/main" id="{E300313F-AAB5-C538-DB0F-406A2C1D3E83}"/>
               </a:ext>
             </a:extLst>
           </p:cNvPr>
@@ -7929,72 +8056,10 @@
           </a:p>
         </p:txBody>
       </p:sp>
-      <p:sp>
-        <p:nvSpPr>
-          <p:cNvPr id="5" name="TextBox 4">
-            <a:extLst>
-              <a:ext uri="{FF2B5EF4-FFF2-40B4-BE49-F238E27FC236}">
-                <a16:creationId xmlns:a16="http://schemas.microsoft.com/office/drawing/2014/main" id="{D6516A4D-AB6D-D775-C407-24586AE5BA23}"/>
-              </a:ext>
-            </a:extLst>
-          </p:cNvPr>
-          <p:cNvSpPr txBox="1"/>
-          <p:nvPr/>
-        </p:nvSpPr>
-        <p:spPr>
-          <a:xfrm>
-            <a:off x="6782639" y="2340077"/>
-            <a:ext cx="2551148" cy="1200329"/>
-          </a:xfrm>
-          <a:prstGeom prst="rect">
-            <a:avLst/>
-          </a:prstGeom>
-          <a:noFill/>
-          <a:ln>
-            <a:solidFill>
-              <a:schemeClr val="tx1"/>
-            </a:solidFill>
-          </a:ln>
-        </p:spPr>
-        <p:txBody>
-          <a:bodyPr wrap="none" rtlCol="0">
-            <a:spAutoFit/>
-          </a:bodyPr>
-          <a:lstStyle/>
-          <a:p>
-            <a:pPr algn="ctr"/>
-            <a:r>
-              <a:rPr lang="en-US" sz="2400" dirty="0"/>
-              <a:t>NVIDIA reference:</a:t>
-            </a:r>
-          </a:p>
-          <a:p>
-            <a:pPr marL="285750" indent="-285750">
-              <a:buFont typeface="Arial" panose="020B0604020202020204" pitchFamily="34" charset="0"/>
-              <a:buChar char="•"/>
-            </a:pPr>
-            <a:r>
-              <a:rPr lang="en-US" sz="2400" dirty="0"/>
-              <a:t>league = grid</a:t>
-            </a:r>
-          </a:p>
-          <a:p>
-            <a:pPr marL="285750" indent="-285750">
-              <a:buFont typeface="Arial" panose="020B0604020202020204" pitchFamily="34" charset="0"/>
-              <a:buChar char="•"/>
-            </a:pPr>
-            <a:r>
-              <a:rPr lang="en-US" sz="2400" dirty="0"/>
-              <a:t>Team = block</a:t>
-            </a:r>
-            <a:endParaRPr lang="LID4096" sz="2400" dirty="0"/>
-          </a:p>
-        </p:txBody>
-      </p:sp>
     </p:spTree>
     <p:extLst>
       <p:ext uri="{BB962C8B-B14F-4D97-AF65-F5344CB8AC3E}">
-        <p14:creationId xmlns:p14="http://schemas.microsoft.com/office/powerpoint/2010/main" val="83176273"/>
+        <p14:creationId xmlns:p14="http://schemas.microsoft.com/office/powerpoint/2010/main" val="2178377177"/>
       </p:ext>
     </p:extLst>
   </p:cSld>
@@ -8144,6 +8209,549 @@
           <p:cNvPr id="2" name="Title 1">
             <a:extLst>
               <a:ext uri="{FF2B5EF4-FFF2-40B4-BE49-F238E27FC236}">
+                <a16:creationId xmlns:a16="http://schemas.microsoft.com/office/drawing/2014/main" id="{B572CA4C-F0C4-A6E1-3EB0-76C4786F3169}"/>
+              </a:ext>
+            </a:extLst>
+          </p:cNvPr>
+          <p:cNvSpPr>
+            <a:spLocks noGrp="1"/>
+          </p:cNvSpPr>
+          <p:nvPr>
+            <p:ph type="title"/>
+          </p:nvPr>
+        </p:nvSpPr>
+        <p:spPr/>
+        <p:txBody>
+          <a:bodyPr/>
+          <a:lstStyle/>
+          <a:p>
+            <a:r>
+              <a:rPr lang="en-US" dirty="0"/>
+              <a:t>Creating teams</a:t>
+            </a:r>
+            <a:endParaRPr lang="LID4096" dirty="0"/>
+          </a:p>
+        </p:txBody>
+      </p:sp>
+      <p:sp>
+        <p:nvSpPr>
+          <p:cNvPr id="3" name="Content Placeholder 2">
+            <a:extLst>
+              <a:ext uri="{FF2B5EF4-FFF2-40B4-BE49-F238E27FC236}">
+                <a16:creationId xmlns:a16="http://schemas.microsoft.com/office/drawing/2014/main" id="{775BFE13-1B24-6A3F-3633-31FB9CA0FC0E}"/>
+              </a:ext>
+            </a:extLst>
+          </p:cNvPr>
+          <p:cNvSpPr>
+            <a:spLocks noGrp="1"/>
+          </p:cNvSpPr>
+          <p:nvPr>
+            <p:ph idx="1"/>
+          </p:nvPr>
+        </p:nvSpPr>
+        <p:spPr/>
+        <p:txBody>
+          <a:bodyPr>
+            <a:normAutofit fontScale="92500" lnSpcReduction="20000"/>
+          </a:bodyPr>
+          <a:lstStyle/>
+          <a:p>
+            <a:r>
+              <a:rPr lang="en-US" dirty="0"/>
+              <a:t>Example</a:t>
+            </a:r>
+            <a:br>
+              <a:rPr lang="en-US" dirty="0"/>
+            </a:br>
+            <a:r>
+              <a:rPr lang="en-US" dirty="0">
+                <a:solidFill>
+                  <a:prstClr val="black"/>
+                </a:solidFill>
+                <a:latin typeface="Courier New" pitchFamily="49" charset="0"/>
+                <a:cs typeface="Courier New" pitchFamily="49" charset="0"/>
+              </a:rPr>
+              <a:t>#pragma </a:t>
+            </a:r>
+            <a:r>
+              <a:rPr lang="en-US" dirty="0" err="1">
+                <a:solidFill>
+                  <a:prstClr val="black"/>
+                </a:solidFill>
+                <a:latin typeface="Courier New" pitchFamily="49" charset="0"/>
+                <a:cs typeface="Courier New" pitchFamily="49" charset="0"/>
+              </a:rPr>
+              <a:t>omp</a:t>
+            </a:r>
+            <a:r>
+              <a:rPr lang="en-US" dirty="0">
+                <a:solidFill>
+                  <a:prstClr val="black"/>
+                </a:solidFill>
+                <a:latin typeface="Courier New" pitchFamily="49" charset="0"/>
+                <a:cs typeface="Courier New" pitchFamily="49" charset="0"/>
+              </a:rPr>
+              <a:t> teams</a:t>
+            </a:r>
+          </a:p>
+          <a:p>
+            <a:endParaRPr lang="en-US" dirty="0">
+              <a:solidFill>
+                <a:prstClr val="black"/>
+              </a:solidFill>
+              <a:latin typeface="Courier New" pitchFamily="49" charset="0"/>
+              <a:cs typeface="Courier New" pitchFamily="49" charset="0"/>
+            </a:endParaRPr>
+          </a:p>
+          <a:p>
+            <a:r>
+              <a:rPr lang="en-US" dirty="0">
+                <a:solidFill>
+                  <a:prstClr val="black"/>
+                </a:solidFill>
+                <a:cs typeface="Courier New" pitchFamily="49" charset="0"/>
+              </a:rPr>
+              <a:t>Creates league of teams</a:t>
+            </a:r>
+          </a:p>
+          <a:p>
+            <a:r>
+              <a:rPr lang="en-US" dirty="0">
+                <a:solidFill>
+                  <a:prstClr val="black"/>
+                </a:solidFill>
+                <a:cs typeface="Courier New" pitchFamily="49" charset="0"/>
+              </a:rPr>
+              <a:t>Each team has single initial thread</a:t>
+            </a:r>
+          </a:p>
+          <a:p>
+            <a:endParaRPr lang="en-US" dirty="0">
+              <a:solidFill>
+                <a:prstClr val="black"/>
+              </a:solidFill>
+              <a:cs typeface="Courier New" pitchFamily="49" charset="0"/>
+            </a:endParaRPr>
+          </a:p>
+          <a:p>
+            <a:r>
+              <a:rPr lang="en-US" dirty="0">
+                <a:solidFill>
+                  <a:prstClr val="black"/>
+                </a:solidFill>
+                <a:cs typeface="Courier New" pitchFamily="49" charset="0"/>
+              </a:rPr>
+              <a:t>Clauses</a:t>
+            </a:r>
+          </a:p>
+          <a:p>
+            <a:pPr lvl="1"/>
+            <a:r>
+              <a:rPr lang="en-US" dirty="0">
+                <a:solidFill>
+                  <a:prstClr val="black"/>
+                </a:solidFill>
+                <a:latin typeface="Courier New" panose="02070309020205020404" pitchFamily="49" charset="0"/>
+                <a:cs typeface="Courier New" panose="02070309020205020404" pitchFamily="49" charset="0"/>
+              </a:rPr>
+              <a:t>private(</a:t>
+            </a:r>
+            <a:r>
+              <a:rPr lang="en-US" dirty="0">
+                <a:solidFill>
+                  <a:prstClr val="black"/>
+                </a:solidFill>
+                <a:latin typeface="Courier New" panose="02070309020205020404" pitchFamily="49" charset="0"/>
+                <a:cs typeface="Courier New" panose="02070309020205020404" pitchFamily="49" charset="0"/>
+                <a:sym typeface="Symbol" panose="05050102010706020507" pitchFamily="18" charset="2"/>
+              </a:rPr>
+              <a:t>)</a:t>
+            </a:r>
+            <a:r>
+              <a:rPr lang="en-US" dirty="0">
+                <a:solidFill>
+                  <a:prstClr val="black"/>
+                </a:solidFill>
+                <a:cs typeface="Courier New" pitchFamily="49" charset="0"/>
+              </a:rPr>
+              <a:t>, </a:t>
+            </a:r>
+            <a:r>
+              <a:rPr lang="en-US" dirty="0" err="1">
+                <a:solidFill>
+                  <a:prstClr val="black"/>
+                </a:solidFill>
+                <a:latin typeface="Courier New" panose="02070309020205020404" pitchFamily="49" charset="0"/>
+                <a:cs typeface="Courier New" panose="02070309020205020404" pitchFamily="49" charset="0"/>
+              </a:rPr>
+              <a:t>firstprivate</a:t>
+            </a:r>
+            <a:r>
+              <a:rPr lang="en-US" dirty="0">
+                <a:solidFill>
+                  <a:prstClr val="black"/>
+                </a:solidFill>
+                <a:latin typeface="Courier New" panose="02070309020205020404" pitchFamily="49" charset="0"/>
+                <a:cs typeface="Courier New" panose="02070309020205020404" pitchFamily="49" charset="0"/>
+              </a:rPr>
+              <a:t>(</a:t>
+            </a:r>
+            <a:r>
+              <a:rPr lang="en-US" dirty="0">
+                <a:solidFill>
+                  <a:prstClr val="black"/>
+                </a:solidFill>
+                <a:latin typeface="Courier New" panose="02070309020205020404" pitchFamily="49" charset="0"/>
+                <a:cs typeface="Courier New" panose="02070309020205020404" pitchFamily="49" charset="0"/>
+                <a:sym typeface="Symbol" panose="05050102010706020507" pitchFamily="18" charset="2"/>
+              </a:rPr>
+              <a:t>)</a:t>
+            </a:r>
+            <a:r>
+              <a:rPr lang="en-US" dirty="0">
+                <a:solidFill>
+                  <a:prstClr val="black"/>
+                </a:solidFill>
+                <a:cs typeface="Courier New" pitchFamily="49" charset="0"/>
+              </a:rPr>
+              <a:t>, </a:t>
+            </a:r>
+            <a:r>
+              <a:rPr lang="en-US" dirty="0">
+                <a:solidFill>
+                  <a:prstClr val="black"/>
+                </a:solidFill>
+                <a:latin typeface="Courier New" panose="02070309020205020404" pitchFamily="49" charset="0"/>
+                <a:cs typeface="Courier New" panose="02070309020205020404" pitchFamily="49" charset="0"/>
+              </a:rPr>
+              <a:t>shared(</a:t>
+            </a:r>
+            <a:r>
+              <a:rPr lang="en-US" dirty="0">
+                <a:solidFill>
+                  <a:prstClr val="black"/>
+                </a:solidFill>
+                <a:latin typeface="Courier New" panose="02070309020205020404" pitchFamily="49" charset="0"/>
+                <a:cs typeface="Courier New" panose="02070309020205020404" pitchFamily="49" charset="0"/>
+                <a:sym typeface="Symbol" panose="05050102010706020507" pitchFamily="18" charset="2"/>
+              </a:rPr>
+              <a:t>)</a:t>
+            </a:r>
+            <a:r>
+              <a:rPr lang="en-US" dirty="0">
+                <a:solidFill>
+                  <a:prstClr val="black"/>
+                </a:solidFill>
+                <a:cs typeface="Courier New" pitchFamily="49" charset="0"/>
+              </a:rPr>
+              <a:t>, </a:t>
+            </a:r>
+            <a:r>
+              <a:rPr lang="en-US" dirty="0">
+                <a:solidFill>
+                  <a:prstClr val="black"/>
+                </a:solidFill>
+                <a:latin typeface="Courier New" panose="02070309020205020404" pitchFamily="49" charset="0"/>
+                <a:cs typeface="Courier New" panose="02070309020205020404" pitchFamily="49" charset="0"/>
+              </a:rPr>
+              <a:t>default(</a:t>
+            </a:r>
+            <a:r>
+              <a:rPr lang="en-US" dirty="0">
+                <a:solidFill>
+                  <a:prstClr val="black"/>
+                </a:solidFill>
+                <a:latin typeface="Courier New" panose="02070309020205020404" pitchFamily="49" charset="0"/>
+                <a:cs typeface="Courier New" panose="02070309020205020404" pitchFamily="49" charset="0"/>
+                <a:sym typeface="Symbol" panose="05050102010706020507" pitchFamily="18" charset="2"/>
+              </a:rPr>
+              <a:t>)</a:t>
+            </a:r>
+            <a:r>
+              <a:rPr lang="en-US" dirty="0">
+                <a:solidFill>
+                  <a:prstClr val="black"/>
+                </a:solidFill>
+                <a:cs typeface="Courier New" pitchFamily="49" charset="0"/>
+              </a:rPr>
+              <a:t>, </a:t>
+            </a:r>
+            <a:r>
+              <a:rPr lang="en-US" dirty="0">
+                <a:solidFill>
+                  <a:prstClr val="black"/>
+                </a:solidFill>
+                <a:latin typeface="Courier New" panose="02070309020205020404" pitchFamily="49" charset="0"/>
+                <a:cs typeface="Courier New" panose="02070309020205020404" pitchFamily="49" charset="0"/>
+              </a:rPr>
+              <a:t>reduction(</a:t>
+            </a:r>
+            <a:r>
+              <a:rPr lang="en-US" dirty="0">
+                <a:solidFill>
+                  <a:prstClr val="black"/>
+                </a:solidFill>
+                <a:latin typeface="Courier New" panose="02070309020205020404" pitchFamily="49" charset="0"/>
+                <a:cs typeface="Courier New" panose="02070309020205020404" pitchFamily="49" charset="0"/>
+                <a:sym typeface="Symbol" panose="05050102010706020507" pitchFamily="18" charset="2"/>
+              </a:rPr>
+              <a:t>)</a:t>
+            </a:r>
+            <a:r>
+              <a:rPr lang="en-US" dirty="0">
+                <a:solidFill>
+                  <a:prstClr val="black"/>
+                </a:solidFill>
+                <a:cs typeface="Courier New" pitchFamily="49" charset="0"/>
+              </a:rPr>
+              <a:t>, </a:t>
+            </a:r>
+            <a:r>
+              <a:rPr lang="en-US" dirty="0">
+                <a:solidFill>
+                  <a:prstClr val="black"/>
+                </a:solidFill>
+                <a:latin typeface="Courier New" panose="02070309020205020404" pitchFamily="49" charset="0"/>
+                <a:cs typeface="Courier New" panose="02070309020205020404" pitchFamily="49" charset="0"/>
+              </a:rPr>
+              <a:t>if(</a:t>
+            </a:r>
+            <a:r>
+              <a:rPr lang="en-US" dirty="0">
+                <a:solidFill>
+                  <a:prstClr val="black"/>
+                </a:solidFill>
+                <a:latin typeface="Courier New" panose="02070309020205020404" pitchFamily="49" charset="0"/>
+                <a:cs typeface="Courier New" panose="02070309020205020404" pitchFamily="49" charset="0"/>
+                <a:sym typeface="Symbol" panose="05050102010706020507" pitchFamily="18" charset="2"/>
+              </a:rPr>
+              <a:t>)</a:t>
+            </a:r>
+            <a:endParaRPr lang="en-US" dirty="0">
+              <a:solidFill>
+                <a:prstClr val="black"/>
+              </a:solidFill>
+              <a:latin typeface="Courier New" panose="02070309020205020404" pitchFamily="49" charset="0"/>
+              <a:cs typeface="Courier New" panose="02070309020205020404" pitchFamily="49" charset="0"/>
+            </a:endParaRPr>
+          </a:p>
+          <a:p>
+            <a:pPr lvl="1"/>
+            <a:r>
+              <a:rPr lang="en-US" dirty="0" err="1">
+                <a:solidFill>
+                  <a:prstClr val="black"/>
+                </a:solidFill>
+                <a:latin typeface="Courier New" panose="02070309020205020404" pitchFamily="49" charset="0"/>
+                <a:cs typeface="Courier New" panose="02070309020205020404" pitchFamily="49" charset="0"/>
+              </a:rPr>
+              <a:t>num_teams</a:t>
+            </a:r>
+            <a:r>
+              <a:rPr lang="en-US" dirty="0">
+                <a:solidFill>
+                  <a:prstClr val="black"/>
+                </a:solidFill>
+                <a:latin typeface="Courier New" panose="02070309020205020404" pitchFamily="49" charset="0"/>
+                <a:cs typeface="Courier New" panose="02070309020205020404" pitchFamily="49" charset="0"/>
+              </a:rPr>
+              <a:t>(</a:t>
+            </a:r>
+            <a:r>
+              <a:rPr lang="en-US" dirty="0">
+                <a:solidFill>
+                  <a:prstClr val="black"/>
+                </a:solidFill>
+                <a:latin typeface="Courier New" panose="02070309020205020404" pitchFamily="49" charset="0"/>
+                <a:cs typeface="Courier New" panose="02070309020205020404" pitchFamily="49" charset="0"/>
+                <a:sym typeface="Symbol" panose="05050102010706020507" pitchFamily="18" charset="2"/>
+              </a:rPr>
+              <a:t>)</a:t>
+            </a:r>
+            <a:endParaRPr lang="en-US" dirty="0">
+              <a:solidFill>
+                <a:prstClr val="black"/>
+              </a:solidFill>
+              <a:latin typeface="Courier New" panose="02070309020205020404" pitchFamily="49" charset="0"/>
+              <a:cs typeface="Courier New" panose="02070309020205020404" pitchFamily="49" charset="0"/>
+            </a:endParaRPr>
+          </a:p>
+          <a:p>
+            <a:pPr lvl="1"/>
+            <a:r>
+              <a:rPr lang="en-US" dirty="0" err="1">
+                <a:solidFill>
+                  <a:prstClr val="black"/>
+                </a:solidFill>
+                <a:latin typeface="Courier New" panose="02070309020205020404" pitchFamily="49" charset="0"/>
+                <a:cs typeface="Courier New" panose="02070309020205020404" pitchFamily="49" charset="0"/>
+              </a:rPr>
+              <a:t>thread_limit</a:t>
+            </a:r>
+            <a:r>
+              <a:rPr lang="en-US" dirty="0">
+                <a:solidFill>
+                  <a:prstClr val="black"/>
+                </a:solidFill>
+                <a:latin typeface="Courier New" panose="02070309020205020404" pitchFamily="49" charset="0"/>
+                <a:cs typeface="Courier New" panose="02070309020205020404" pitchFamily="49" charset="0"/>
+              </a:rPr>
+              <a:t>(</a:t>
+            </a:r>
+            <a:r>
+              <a:rPr lang="en-US" dirty="0">
+                <a:solidFill>
+                  <a:prstClr val="black"/>
+                </a:solidFill>
+                <a:latin typeface="Courier New" panose="02070309020205020404" pitchFamily="49" charset="0"/>
+                <a:cs typeface="Courier New" panose="02070309020205020404" pitchFamily="49" charset="0"/>
+                <a:sym typeface="Symbol" panose="05050102010706020507" pitchFamily="18" charset="2"/>
+              </a:rPr>
+              <a:t>)</a:t>
+            </a:r>
+          </a:p>
+          <a:p>
+            <a:pPr lvl="1"/>
+            <a:r>
+              <a:rPr lang="en-US" dirty="0">
+                <a:solidFill>
+                  <a:prstClr val="black"/>
+                </a:solidFill>
+                <a:cs typeface="Courier New" pitchFamily="49" charset="0"/>
+                <a:sym typeface="Symbol" panose="05050102010706020507" pitchFamily="18" charset="2"/>
+              </a:rPr>
+              <a:t></a:t>
+            </a:r>
+            <a:endParaRPr lang="LID4096" dirty="0"/>
+          </a:p>
+        </p:txBody>
+      </p:sp>
+      <p:sp>
+        <p:nvSpPr>
+          <p:cNvPr id="4" name="Slide Number Placeholder 3">
+            <a:extLst>
+              <a:ext uri="{FF2B5EF4-FFF2-40B4-BE49-F238E27FC236}">
+                <a16:creationId xmlns:a16="http://schemas.microsoft.com/office/drawing/2014/main" id="{849DE019-3110-99A0-75BE-DDBC7982872A}"/>
+              </a:ext>
+            </a:extLst>
+          </p:cNvPr>
+          <p:cNvSpPr>
+            <a:spLocks noGrp="1"/>
+          </p:cNvSpPr>
+          <p:nvPr>
+            <p:ph type="sldNum" sz="quarter" idx="12"/>
+          </p:nvPr>
+        </p:nvSpPr>
+        <p:spPr/>
+        <p:txBody>
+          <a:bodyPr/>
+          <a:lstStyle/>
+          <a:p>
+            <a:fld id="{9C7CE217-4467-4B8D-A735-B008FA7C4816}" type="slidenum">
+              <a:rPr lang="LID4096" smtClean="0"/>
+              <a:t>20</a:t>
+            </a:fld>
+            <a:endParaRPr lang="LID4096"/>
+          </a:p>
+        </p:txBody>
+      </p:sp>
+      <p:sp>
+        <p:nvSpPr>
+          <p:cNvPr id="5" name="TextBox 4">
+            <a:extLst>
+              <a:ext uri="{FF2B5EF4-FFF2-40B4-BE49-F238E27FC236}">
+                <a16:creationId xmlns:a16="http://schemas.microsoft.com/office/drawing/2014/main" id="{D6516A4D-AB6D-D775-C407-24586AE5BA23}"/>
+              </a:ext>
+            </a:extLst>
+          </p:cNvPr>
+          <p:cNvSpPr txBox="1"/>
+          <p:nvPr/>
+        </p:nvSpPr>
+        <p:spPr>
+          <a:xfrm>
+            <a:off x="6782639" y="2340077"/>
+            <a:ext cx="2551148" cy="1200329"/>
+          </a:xfrm>
+          <a:prstGeom prst="rect">
+            <a:avLst/>
+          </a:prstGeom>
+          <a:noFill/>
+          <a:ln>
+            <a:solidFill>
+              <a:schemeClr val="tx1"/>
+            </a:solidFill>
+          </a:ln>
+        </p:spPr>
+        <p:txBody>
+          <a:bodyPr wrap="none" rtlCol="0">
+            <a:spAutoFit/>
+          </a:bodyPr>
+          <a:lstStyle/>
+          <a:p>
+            <a:pPr algn="ctr"/>
+            <a:r>
+              <a:rPr lang="en-US" sz="2400" dirty="0"/>
+              <a:t>NVIDIA reference:</a:t>
+            </a:r>
+          </a:p>
+          <a:p>
+            <a:pPr marL="285750" indent="-285750">
+              <a:buFont typeface="Arial" panose="020B0604020202020204" pitchFamily="34" charset="0"/>
+              <a:buChar char="•"/>
+            </a:pPr>
+            <a:r>
+              <a:rPr lang="en-US" sz="2400" dirty="0"/>
+              <a:t>league = grid</a:t>
+            </a:r>
+          </a:p>
+          <a:p>
+            <a:pPr marL="285750" indent="-285750">
+              <a:buFont typeface="Arial" panose="020B0604020202020204" pitchFamily="34" charset="0"/>
+              <a:buChar char="•"/>
+            </a:pPr>
+            <a:r>
+              <a:rPr lang="en-US" sz="2400" dirty="0"/>
+              <a:t>Team = block</a:t>
+            </a:r>
+            <a:endParaRPr lang="LID4096" sz="2400" dirty="0"/>
+          </a:p>
+        </p:txBody>
+      </p:sp>
+    </p:spTree>
+    <p:extLst>
+      <p:ext uri="{BB962C8B-B14F-4D97-AF65-F5344CB8AC3E}">
+        <p14:creationId xmlns:p14="http://schemas.microsoft.com/office/powerpoint/2010/main" val="83176273"/>
+      </p:ext>
+    </p:extLst>
+  </p:cSld>
+  <p:clrMapOvr>
+    <a:masterClrMapping/>
+  </p:clrMapOvr>
+</p:sld>
+</file>
+
+<file path=ppt/slides/slide21.xml><?xml version="1.0" encoding="utf-8"?>
+<p:sld xmlns:a="http://schemas.openxmlformats.org/drawingml/2006/main" xmlns:r="http://schemas.openxmlformats.org/officeDocument/2006/relationships" xmlns:p="http://schemas.openxmlformats.org/presentationml/2006/main">
+  <p:cSld>
+    <p:spTree>
+      <p:nvGrpSpPr>
+        <p:cNvPr id="1" name=""/>
+        <p:cNvGrpSpPr/>
+        <p:nvPr/>
+      </p:nvGrpSpPr>
+      <p:grpSpPr>
+        <a:xfrm>
+          <a:off x="0" y="0"/>
+          <a:ext cx="0" cy="0"/>
+          <a:chOff x="0" y="0"/>
+          <a:chExt cx="0" cy="0"/>
+        </a:xfrm>
+      </p:grpSpPr>
+      <p:sp>
+        <p:nvSpPr>
+          <p:cNvPr id="2" name="Title 1">
+            <a:extLst>
+              <a:ext uri="{FF2B5EF4-FFF2-40B4-BE49-F238E27FC236}">
                 <a16:creationId xmlns:a16="http://schemas.microsoft.com/office/drawing/2014/main" id="{E67EA1D2-0790-257F-0FD2-2EB5B9143E98}"/>
               </a:ext>
             </a:extLst>
@@ -8402,7 +9010,7 @@
           <a:p>
             <a:fld id="{9C7CE217-4467-4B8D-A735-B008FA7C4816}" type="slidenum">
               <a:rPr lang="LID4096" smtClean="0"/>
-              <a:t>20</a:t>
+              <a:t>21</a:t>
             </a:fld>
             <a:endParaRPr lang="LID4096"/>
           </a:p>
@@ -8421,7 +9029,7 @@
 </p:sld>
 </file>
 
-<file path=ppt/slides/slide21.xml><?xml version="1.0" encoding="utf-8"?>
+<file path=ppt/slides/slide22.xml><?xml version="1.0" encoding="utf-8"?>
 <p:sld xmlns:a="http://schemas.openxmlformats.org/drawingml/2006/main" xmlns:r="http://schemas.openxmlformats.org/officeDocument/2006/relationships" xmlns:p="http://schemas.openxmlformats.org/presentationml/2006/main">
   <p:cSld>
     <p:spTree>
@@ -8490,7 +9098,7 @@
           <a:p>
             <a:fld id="{9C7CE217-4467-4B8D-A735-B008FA7C4816}" type="slidenum">
               <a:rPr lang="LID4096" smtClean="0"/>
-              <a:t>21</a:t>
+              <a:t>22</a:t>
             </a:fld>
             <a:endParaRPr lang="LID4096"/>
           </a:p>
@@ -10189,7 +10797,7 @@
 </p:sld>
 </file>
 
-<file path=ppt/slides/slide22.xml><?xml version="1.0" encoding="utf-8"?>
+<file path=ppt/slides/slide23.xml><?xml version="1.0" encoding="utf-8"?>
 <p:sld xmlns:a="http://schemas.openxmlformats.org/drawingml/2006/main" xmlns:r="http://schemas.openxmlformats.org/officeDocument/2006/relationships" xmlns:p="http://schemas.openxmlformats.org/presentationml/2006/main">
   <p:cSld>
     <p:spTree>
@@ -10258,7 +10866,7 @@
           <a:p>
             <a:fld id="{9C7CE217-4467-4B8D-A735-B008FA7C4816}" type="slidenum">
               <a:rPr lang="LID4096" smtClean="0"/>
-              <a:t>22</a:t>
+              <a:t>23</a:t>
             </a:fld>
             <a:endParaRPr lang="LID4096"/>
           </a:p>
@@ -12161,7 +12769,7 @@
 </p:sld>
 </file>
 
-<file path=ppt/slides/slide23.xml><?xml version="1.0" encoding="utf-8"?>
+<file path=ppt/slides/slide24.xml><?xml version="1.0" encoding="utf-8"?>
 <p:sld xmlns:a="http://schemas.openxmlformats.org/drawingml/2006/main" xmlns:r="http://schemas.openxmlformats.org/officeDocument/2006/relationships" xmlns:p="http://schemas.openxmlformats.org/presentationml/2006/main">
   <p:cSld>
     <p:spTree>
@@ -12339,7 +12947,7 @@
           <a:p>
             <a:fld id="{9C7CE217-4467-4B8D-A735-B008FA7C4816}" type="slidenum">
               <a:rPr lang="LID4096" smtClean="0"/>
-              <a:t>23</a:t>
+              <a:t>24</a:t>
             </a:fld>
             <a:endParaRPr lang="LID4096"/>
           </a:p>
@@ -12358,7 +12966,7 @@
 </p:sld>
 </file>
 
-<file path=ppt/slides/slide24.xml><?xml version="1.0" encoding="utf-8"?>
+<file path=ppt/slides/slide25.xml><?xml version="1.0" encoding="utf-8"?>
 <p:sld xmlns:a="http://schemas.openxmlformats.org/drawingml/2006/main" xmlns:r="http://schemas.openxmlformats.org/officeDocument/2006/relationships" xmlns:p="http://schemas.openxmlformats.org/presentationml/2006/main">
   <p:cSld>
     <p:spTree>
@@ -13149,7 +13757,7 @@
           <a:p>
             <a:fld id="{9C7CE217-4467-4B8D-A735-B008FA7C4816}" type="slidenum">
               <a:rPr lang="LID4096" smtClean="0"/>
-              <a:t>24</a:t>
+              <a:t>25</a:t>
             </a:fld>
             <a:endParaRPr lang="LID4096"/>
           </a:p>

</xml_diff>